<commit_message>
fix: typo 'kool' -> 'cool' on slide 5, refresh dist
Co-Authored-By: Claude Sonnet 4.6 <noreply@anthropic.com>
</commit_message>
<xml_diff>
--- a/dist/bitcoincierge_pitch_deck.pptx
+++ b/dist/bitcoincierge_pitch_deck.pptx
@@ -10084,7 +10084,7 @@
                 <a:ea typeface="Georgia" pitchFamily="34" charset="-122"/>
                 <a:cs typeface="Georgia" pitchFamily="34" charset="-120"/>
               </a:rPr>
-              <a:t>The other 1.4 billion Indians? They've never thought about Bitcoin. Not once.</a:t>
+              <a:t>And for rest of 1.4 billion Indians - Bitcoin is still not a real thing!</a:t>
             </a:r>
             <a:endParaRPr lang="en-US" sz="1600" dirty="0"/>
           </a:p>
@@ -10175,7 +10175,7 @@
                 <a:ea typeface="Calibri" pitchFamily="34" charset="-122"/>
                 <a:cs typeface="Calibri" pitchFamily="34" charset="-120"/>
               </a:rPr>
-              <a:t>M A R K E T I N G   C H A N N E L   1   /   3</a:t>
+              <a:t>O R G A N I C   M A R K E T I N G   P R O B L E M</a:t>
             </a:r>
             <a:endParaRPr lang="en-US" sz="850" dirty="0"/>
           </a:p>
@@ -10189,8 +10189,8 @@
         </p:nvSpPr>
         <p:spPr>
           <a:xfrm>
-            <a:off x="457200" y="502920"/>
-            <a:ext cx="8229600" cy="594360"/>
+            <a:off x="457200" y="411480"/>
+            <a:ext cx="8229600" cy="685800"/>
           </a:xfrm>
           <a:prstGeom prst="rect">
             <a:avLst/>
@@ -10206,7 +10206,7 @@
               <a:buNone/>
             </a:pPr>
             <a:r>
-              <a:rPr lang="en-US" sz="3200" i="1" dirty="0">
+              <a:rPr lang="en-US" sz="3600" i="1" dirty="0">
                 <a:solidFill>
                   <a:srgbClr val="1A1A1A"/>
                 </a:solidFill>
@@ -10214,47 +10214,46 @@
                 <a:ea typeface="Georgia" pitchFamily="34" charset="-122"/>
                 <a:cs typeface="Georgia" pitchFamily="34" charset="-120"/>
               </a:rPr>
-              <a:t>Want to run Bitcoin ads?</a:t>
-            </a:r>
-            <a:endParaRPr lang="en-US" sz="3200" dirty="0"/>
-          </a:p>
-        </p:txBody>
-      </p:sp>
-      <p:sp>
-        <p:nvSpPr>
-          <p:cNvPr id="5" name="Shape 3"/>
-          <p:cNvSpPr/>
-          <p:nvPr/>
-        </p:nvSpPr>
-        <p:spPr>
-          <a:xfrm>
-            <a:off x="1645920" y="1234440"/>
-            <a:ext cx="5852160" cy="1417320"/>
-          </a:xfrm>
-          <a:prstGeom prst="rect">
-            <a:avLst/>
-          </a:prstGeom>
-          <a:solidFill>
-            <a:srgbClr val="FCE8D5"/>
-          </a:solidFill>
-          <a:ln w="63500">
-            <a:solidFill>
-              <a:srgbClr val="DC2626"/>
-            </a:solidFill>
-            <a:prstDash val="solid"/>
-          </a:ln>
-        </p:spPr>
-      </p:sp>
-      <p:sp>
-        <p:nvSpPr>
-          <p:cNvPr id="6" name="Text 4"/>
-          <p:cNvSpPr/>
-          <p:nvPr/>
-        </p:nvSpPr>
-        <p:spPr>
-          <a:xfrm>
-            <a:off x="1645920" y="1234440"/>
-            <a:ext cx="5852160" cy="1417320"/>
+              <a:t>AI is the new cool kid</a:t>
+            </a:r>
+            <a:endParaRPr lang="en-US" sz="3600" dirty="0"/>
+          </a:p>
+        </p:txBody>
+      </p:sp>
+      <p:pic>
+        <p:nvPicPr>
+          <p:cNvPr id="5" name="Image 0" descr="/Users/sov/bitcoincierge-pitch-deck 3/assets/processed/ai_robot.png">    </p:cNvPr>
+          <p:cNvPicPr>
+            <a:picLocks noChangeAspect="1"/>
+          </p:cNvPicPr>
+          <p:nvPr/>
+        </p:nvPicPr>
+        <p:blipFill>
+          <a:blip r:embed="rId1"/>
+          <a:stretch>
+            <a:fillRect/>
+          </a:stretch>
+        </p:blipFill>
+        <p:spPr>
+          <a:xfrm>
+            <a:off x="1097280" y="1371600"/>
+            <a:ext cx="2560320" cy="2560320"/>
+          </a:xfrm>
+          <a:prstGeom prst="rect">
+            <a:avLst/>
+          </a:prstGeom>
+        </p:spPr>
+      </p:pic>
+      <p:sp>
+        <p:nvSpPr>
+          <p:cNvPr id="6" name="Text 3"/>
+          <p:cNvSpPr/>
+          <p:nvPr/>
+        </p:nvSpPr>
+        <p:spPr>
+          <a:xfrm>
+            <a:off x="3657600" y="1463040"/>
+            <a:ext cx="1828800" cy="2286000"/>
           </a:xfrm>
           <a:prstGeom prst="rect">
             <a:avLst/>
@@ -10270,506 +10269,44 @@
               <a:buNone/>
             </a:pPr>
             <a:r>
-              <a:rPr lang="en-US" sz="7200" b="1" dirty="0">
-                <a:solidFill>
-                  <a:srgbClr val="DC2626"/>
+              <a:rPr lang="en-US" sz="8000" b="1" dirty="0">
+                <a:solidFill>
+                  <a:srgbClr val="8C5A3A"/>
                 </a:solidFill>
                 <a:latin typeface="Georgia" pitchFamily="34" charset="0"/>
                 <a:ea typeface="Georgia" pitchFamily="34" charset="-122"/>
                 <a:cs typeface="Georgia" pitchFamily="34" charset="-120"/>
               </a:rPr>
-              <a:t>REJECTED.</a:t>
-            </a:r>
-            <a:endParaRPr lang="en-US" sz="7200" dirty="0"/>
-          </a:p>
-        </p:txBody>
-      </p:sp>
-      <p:sp>
-        <p:nvSpPr>
-          <p:cNvPr id="7" name="Shape 5"/>
-          <p:cNvSpPr/>
-          <p:nvPr/>
-        </p:nvSpPr>
-        <p:spPr>
-          <a:xfrm>
-            <a:off x="365760" y="2743200"/>
-            <a:ext cx="2697480" cy="2103120"/>
-          </a:xfrm>
-          <a:prstGeom prst="rect">
-            <a:avLst/>
-          </a:prstGeom>
-          <a:solidFill>
-            <a:srgbClr val="FCE8D5"/>
-          </a:solidFill>
-          <a:ln w="12700">
-            <a:solidFill>
-              <a:srgbClr val="F5C49A"/>
-            </a:solidFill>
-            <a:prstDash val="solid"/>
-          </a:ln>
-        </p:spPr>
-      </p:sp>
-      <p:sp>
-        <p:nvSpPr>
-          <p:cNvPr id="8" name="Shape 6"/>
-          <p:cNvSpPr/>
-          <p:nvPr/>
-        </p:nvSpPr>
-        <p:spPr>
-          <a:xfrm>
-            <a:off x="365760" y="2743200"/>
-            <a:ext cx="2697480" cy="50292"/>
-          </a:xfrm>
-          <a:prstGeom prst="rect">
-            <a:avLst/>
-          </a:prstGeom>
-          <a:solidFill>
-            <a:srgbClr val="DC2626"/>
-          </a:solidFill>
-          <a:ln/>
-        </p:spPr>
-      </p:sp>
-      <p:sp>
-        <p:nvSpPr>
-          <p:cNvPr id="9" name="Text 7"/>
-          <p:cNvSpPr/>
-          <p:nvPr/>
-        </p:nvSpPr>
-        <p:spPr>
-          <a:xfrm>
-            <a:off x="502920" y="2834640"/>
-            <a:ext cx="2423160" cy="822960"/>
-          </a:xfrm>
-          <a:prstGeom prst="rect">
-            <a:avLst/>
-          </a:prstGeom>
-          <a:noFill/>
-          <a:ln/>
-        </p:spPr>
-        <p:txBody>
-          <a:bodyPr wrap="square" lIns="0" tIns="0" rIns="0" bIns="0" rtlCol="0" anchor="ctr"/>
-          <a:lstStyle/>
-          <a:p>
-            <a:pPr algn="ctr" indent="0" marL="0">
-              <a:buNone/>
-            </a:pPr>
-            <a:r>
-              <a:rPr lang="en-US" sz="4200" b="1" dirty="0">
-                <a:solidFill>
-                  <a:srgbClr val="4285F4"/>
-                </a:solidFill>
-                <a:latin typeface="Georgia" pitchFamily="34" charset="0"/>
-                <a:ea typeface="Georgia" pitchFamily="34" charset="-122"/>
-                <a:cs typeface="Georgia" pitchFamily="34" charset="-120"/>
-              </a:rPr>
-              <a:t>G</a:t>
-            </a:r>
-            <a:endParaRPr lang="en-US" sz="4200" dirty="0"/>
-          </a:p>
-        </p:txBody>
-      </p:sp>
-      <p:sp>
-        <p:nvSpPr>
-          <p:cNvPr id="10" name="Text 8"/>
-          <p:cNvSpPr/>
-          <p:nvPr/>
-        </p:nvSpPr>
-        <p:spPr>
-          <a:xfrm>
-            <a:off x="502920" y="3703320"/>
-            <a:ext cx="2423160" cy="320040"/>
-          </a:xfrm>
-          <a:prstGeom prst="rect">
-            <a:avLst/>
-          </a:prstGeom>
-          <a:noFill/>
-          <a:ln/>
-        </p:spPr>
-        <p:txBody>
-          <a:bodyPr wrap="square" lIns="0" tIns="0" rIns="0" bIns="0" rtlCol="0" anchor="ctr"/>
-          <a:lstStyle/>
-          <a:p>
-            <a:pPr algn="ctr" indent="0" marL="0">
-              <a:buNone/>
-            </a:pPr>
-            <a:r>
-              <a:rPr lang="en-US" sz="1100" b="1" dirty="0">
-                <a:solidFill>
-                  <a:srgbClr val="1A1A1A"/>
-                </a:solidFill>
-                <a:latin typeface="Calibri" pitchFamily="34" charset="0"/>
-                <a:ea typeface="Calibri" pitchFamily="34" charset="-122"/>
-                <a:cs typeface="Calibri" pitchFamily="34" charset="-120"/>
-              </a:rPr>
-              <a:t>Google Ads</a:t>
-            </a:r>
-            <a:endParaRPr lang="en-US" sz="1100" dirty="0"/>
-          </a:p>
-        </p:txBody>
-      </p:sp>
-      <p:sp>
-        <p:nvSpPr>
-          <p:cNvPr id="11" name="Text 9"/>
-          <p:cNvSpPr/>
-          <p:nvPr/>
-        </p:nvSpPr>
-        <p:spPr>
-          <a:xfrm>
-            <a:off x="502920" y="4069080"/>
-            <a:ext cx="2423160" cy="640080"/>
-          </a:xfrm>
-          <a:prstGeom prst="rect">
-            <a:avLst/>
-          </a:prstGeom>
-          <a:noFill/>
-          <a:ln/>
-        </p:spPr>
-        <p:txBody>
-          <a:bodyPr wrap="square" lIns="0" tIns="0" rIns="0" bIns="0" rtlCol="0" anchor="ctr"/>
-          <a:lstStyle/>
-          <a:p>
-            <a:pPr algn="ctr" indent="0" marL="0">
-              <a:buNone/>
-            </a:pPr>
-            <a:r>
-              <a:rPr lang="en-US" sz="850" dirty="0">
-                <a:solidFill>
-                  <a:srgbClr val="8C5A3A"/>
-                </a:solidFill>
-                <a:latin typeface="Calibri" pitchFamily="34" charset="0"/>
-                <a:ea typeface="Calibri" pitchFamily="34" charset="-122"/>
-                <a:cs typeface="Calibri" pitchFamily="34" charset="-120"/>
-              </a:rPr>
-              <a:t>Crypto advertising requires certification &amp; ongoing compliance</a:t>
-            </a:r>
-            <a:endParaRPr lang="en-US" sz="850" dirty="0"/>
-          </a:p>
-        </p:txBody>
-      </p:sp>
-      <p:sp>
-        <p:nvSpPr>
-          <p:cNvPr id="12" name="Shape 10"/>
-          <p:cNvSpPr/>
-          <p:nvPr/>
-        </p:nvSpPr>
-        <p:spPr>
-          <a:xfrm>
-            <a:off x="3200400" y="2743200"/>
-            <a:ext cx="2697480" cy="2103120"/>
-          </a:xfrm>
-          <a:prstGeom prst="rect">
-            <a:avLst/>
-          </a:prstGeom>
-          <a:solidFill>
-            <a:srgbClr val="FCE8D5"/>
-          </a:solidFill>
-          <a:ln w="12700">
-            <a:solidFill>
-              <a:srgbClr val="F5C49A"/>
-            </a:solidFill>
-            <a:prstDash val="solid"/>
-          </a:ln>
-        </p:spPr>
-      </p:sp>
-      <p:sp>
-        <p:nvSpPr>
-          <p:cNvPr id="13" name="Shape 11"/>
-          <p:cNvSpPr/>
-          <p:nvPr/>
-        </p:nvSpPr>
-        <p:spPr>
-          <a:xfrm>
-            <a:off x="3200400" y="2743200"/>
-            <a:ext cx="2697480" cy="50292"/>
-          </a:xfrm>
-          <a:prstGeom prst="rect">
-            <a:avLst/>
-          </a:prstGeom>
-          <a:solidFill>
-            <a:srgbClr val="DC2626"/>
-          </a:solidFill>
-          <a:ln/>
-        </p:spPr>
-      </p:sp>
-      <p:sp>
-        <p:nvSpPr>
-          <p:cNvPr id="14" name="Text 12"/>
-          <p:cNvSpPr/>
-          <p:nvPr/>
-        </p:nvSpPr>
-        <p:spPr>
-          <a:xfrm>
-            <a:off x="3337560" y="2834640"/>
-            <a:ext cx="2423160" cy="822960"/>
-          </a:xfrm>
-          <a:prstGeom prst="rect">
-            <a:avLst/>
-          </a:prstGeom>
-          <a:noFill/>
-          <a:ln/>
-        </p:spPr>
-        <p:txBody>
-          <a:bodyPr wrap="square" lIns="0" tIns="0" rIns="0" bIns="0" rtlCol="0" anchor="ctr"/>
-          <a:lstStyle/>
-          <a:p>
-            <a:pPr algn="ctr" indent="0" marL="0">
-              <a:buNone/>
-            </a:pPr>
-            <a:r>
-              <a:rPr lang="en-US" sz="4200" b="1" dirty="0">
-                <a:solidFill>
-                  <a:srgbClr val="0082FB"/>
-                </a:solidFill>
-                <a:latin typeface="Georgia" pitchFamily="34" charset="0"/>
-                <a:ea typeface="Georgia" pitchFamily="34" charset="-122"/>
-                <a:cs typeface="Georgia" pitchFamily="34" charset="-120"/>
-              </a:rPr>
-              <a:t>M</a:t>
-            </a:r>
-            <a:endParaRPr lang="en-US" sz="4200" dirty="0"/>
-          </a:p>
-        </p:txBody>
-      </p:sp>
-      <p:sp>
-        <p:nvSpPr>
-          <p:cNvPr id="15" name="Text 13"/>
-          <p:cNvSpPr/>
-          <p:nvPr/>
-        </p:nvSpPr>
-        <p:spPr>
-          <a:xfrm>
-            <a:off x="3337560" y="3703320"/>
-            <a:ext cx="2423160" cy="320040"/>
-          </a:xfrm>
-          <a:prstGeom prst="rect">
-            <a:avLst/>
-          </a:prstGeom>
-          <a:noFill/>
-          <a:ln/>
-        </p:spPr>
-        <p:txBody>
-          <a:bodyPr wrap="square" lIns="0" tIns="0" rIns="0" bIns="0" rtlCol="0" anchor="ctr"/>
-          <a:lstStyle/>
-          <a:p>
-            <a:pPr algn="ctr" indent="0" marL="0">
-              <a:buNone/>
-            </a:pPr>
-            <a:r>
-              <a:rPr lang="en-US" sz="1100" b="1" dirty="0">
-                <a:solidFill>
-                  <a:srgbClr val="1A1A1A"/>
-                </a:solidFill>
-                <a:latin typeface="Calibri" pitchFamily="34" charset="0"/>
-                <a:ea typeface="Calibri" pitchFamily="34" charset="-122"/>
-                <a:cs typeface="Calibri" pitchFamily="34" charset="-120"/>
-              </a:rPr>
-              <a:t>Meta / Instagram</a:t>
-            </a:r>
-            <a:endParaRPr lang="en-US" sz="1100" dirty="0"/>
-          </a:p>
-        </p:txBody>
-      </p:sp>
-      <p:sp>
-        <p:nvSpPr>
-          <p:cNvPr id="16" name="Text 14"/>
-          <p:cNvSpPr/>
-          <p:nvPr/>
-        </p:nvSpPr>
-        <p:spPr>
-          <a:xfrm>
-            <a:off x="3337560" y="4069080"/>
-            <a:ext cx="2423160" cy="640080"/>
-          </a:xfrm>
-          <a:prstGeom prst="rect">
-            <a:avLst/>
-          </a:prstGeom>
-          <a:noFill/>
-          <a:ln/>
-        </p:spPr>
-        <p:txBody>
-          <a:bodyPr wrap="square" lIns="0" tIns="0" rIns="0" bIns="0" rtlCol="0" anchor="ctr"/>
-          <a:lstStyle/>
-          <a:p>
-            <a:pPr algn="ctr" indent="0" marL="0">
-              <a:buNone/>
-            </a:pPr>
-            <a:r>
-              <a:rPr lang="en-US" sz="850" dirty="0">
-                <a:solidFill>
-                  <a:srgbClr val="8C5A3A"/>
-                </a:solidFill>
-                <a:latin typeface="Calibri" pitchFamily="34" charset="0"/>
-                <a:ea typeface="Calibri" pitchFamily="34" charset="-122"/>
-                <a:cs typeface="Calibri" pitchFamily="34" charset="-120"/>
-              </a:rPr>
-              <a:t>Crypto ads require prior written permission. Often denied.</a:t>
-            </a:r>
-            <a:endParaRPr lang="en-US" sz="850" dirty="0"/>
-          </a:p>
-        </p:txBody>
-      </p:sp>
-      <p:sp>
-        <p:nvSpPr>
-          <p:cNvPr id="17" name="Shape 15"/>
-          <p:cNvSpPr/>
-          <p:nvPr/>
-        </p:nvSpPr>
-        <p:spPr>
-          <a:xfrm>
-            <a:off x="6035040" y="2743200"/>
-            <a:ext cx="2697480" cy="2103120"/>
-          </a:xfrm>
-          <a:prstGeom prst="rect">
-            <a:avLst/>
-          </a:prstGeom>
-          <a:solidFill>
-            <a:srgbClr val="FCE8D5"/>
-          </a:solidFill>
-          <a:ln w="12700">
-            <a:solidFill>
-              <a:srgbClr val="F5C49A"/>
-            </a:solidFill>
-            <a:prstDash val="solid"/>
-          </a:ln>
-        </p:spPr>
-      </p:sp>
-      <p:sp>
-        <p:nvSpPr>
-          <p:cNvPr id="18" name="Shape 16"/>
-          <p:cNvSpPr/>
-          <p:nvPr/>
-        </p:nvSpPr>
-        <p:spPr>
-          <a:xfrm>
-            <a:off x="6035040" y="2743200"/>
-            <a:ext cx="2697480" cy="50292"/>
-          </a:xfrm>
-          <a:prstGeom prst="rect">
-            <a:avLst/>
-          </a:prstGeom>
-          <a:solidFill>
-            <a:srgbClr val="DC2626"/>
-          </a:solidFill>
-          <a:ln/>
-        </p:spPr>
-      </p:sp>
-      <p:sp>
-        <p:nvSpPr>
-          <p:cNvPr id="19" name="Text 17"/>
-          <p:cNvSpPr/>
-          <p:nvPr/>
-        </p:nvSpPr>
-        <p:spPr>
-          <a:xfrm>
-            <a:off x="6172200" y="2834640"/>
-            <a:ext cx="2423160" cy="822960"/>
-          </a:xfrm>
-          <a:prstGeom prst="rect">
-            <a:avLst/>
-          </a:prstGeom>
-          <a:noFill/>
-          <a:ln/>
-        </p:spPr>
-        <p:txBody>
-          <a:bodyPr wrap="square" lIns="0" tIns="0" rIns="0" bIns="0" rtlCol="0" anchor="ctr"/>
-          <a:lstStyle/>
-          <a:p>
-            <a:pPr algn="ctr" indent="0" marL="0">
-              <a:buNone/>
-            </a:pPr>
-            <a:r>
-              <a:rPr lang="en-US" sz="4200" b="1" dirty="0">
-                <a:solidFill>
-                  <a:srgbClr val="FFFFFF"/>
-                </a:solidFill>
-                <a:latin typeface="Georgia" pitchFamily="34" charset="0"/>
-                <a:ea typeface="Georgia" pitchFamily="34" charset="-122"/>
-                <a:cs typeface="Georgia" pitchFamily="34" charset="-120"/>
-              </a:rPr>
-              <a:t>𝕏</a:t>
-            </a:r>
-            <a:endParaRPr lang="en-US" sz="4200" dirty="0"/>
-          </a:p>
-        </p:txBody>
-      </p:sp>
-      <p:sp>
-        <p:nvSpPr>
-          <p:cNvPr id="20" name="Text 18"/>
-          <p:cNvSpPr/>
-          <p:nvPr/>
-        </p:nvSpPr>
-        <p:spPr>
-          <a:xfrm>
-            <a:off x="6172200" y="3703320"/>
-            <a:ext cx="2423160" cy="320040"/>
-          </a:xfrm>
-          <a:prstGeom prst="rect">
-            <a:avLst/>
-          </a:prstGeom>
-          <a:noFill/>
-          <a:ln/>
-        </p:spPr>
-        <p:txBody>
-          <a:bodyPr wrap="square" lIns="0" tIns="0" rIns="0" bIns="0" rtlCol="0" anchor="ctr"/>
-          <a:lstStyle/>
-          <a:p>
-            <a:pPr algn="ctr" indent="0" marL="0">
-              <a:buNone/>
-            </a:pPr>
-            <a:r>
-              <a:rPr lang="en-US" sz="1100" b="1" dirty="0">
-                <a:solidFill>
-                  <a:srgbClr val="1A1A1A"/>
-                </a:solidFill>
-                <a:latin typeface="Calibri" pitchFamily="34" charset="0"/>
-                <a:ea typeface="Calibri" pitchFamily="34" charset="-122"/>
-                <a:cs typeface="Calibri" pitchFamily="34" charset="-120"/>
-              </a:rPr>
-              <a:t>Twitter / X</a:t>
-            </a:r>
-            <a:endParaRPr lang="en-US" sz="1100" dirty="0"/>
-          </a:p>
-        </p:txBody>
-      </p:sp>
-      <p:sp>
-        <p:nvSpPr>
-          <p:cNvPr id="21" name="Text 19"/>
-          <p:cNvSpPr/>
-          <p:nvPr/>
-        </p:nvSpPr>
-        <p:spPr>
-          <a:xfrm>
-            <a:off x="6172200" y="4069080"/>
-            <a:ext cx="2423160" cy="640080"/>
-          </a:xfrm>
-          <a:prstGeom prst="rect">
-            <a:avLst/>
-          </a:prstGeom>
-          <a:noFill/>
-          <a:ln/>
-        </p:spPr>
-        <p:txBody>
-          <a:bodyPr wrap="square" lIns="0" tIns="0" rIns="0" bIns="0" rtlCol="0" anchor="ctr"/>
-          <a:lstStyle/>
-          <a:p>
-            <a:pPr algn="ctr" indent="0" marL="0">
-              <a:buNone/>
-            </a:pPr>
-            <a:r>
-              <a:rPr lang="en-US" sz="850" dirty="0">
-                <a:solidFill>
-                  <a:srgbClr val="8C5A3A"/>
-                </a:solidFill>
-                <a:latin typeface="Calibri" pitchFamily="34" charset="0"/>
-                <a:ea typeface="Calibri" pitchFamily="34" charset="-122"/>
-                <a:cs typeface="Calibri" pitchFamily="34" charset="-120"/>
-              </a:rPr>
-              <a:t>Allowed but requires financial services certification per market</a:t>
-            </a:r>
-            <a:endParaRPr lang="en-US" sz="850" dirty="0"/>
-          </a:p>
-        </p:txBody>
-      </p:sp>
+              <a:t>&gt;</a:t>
+            </a:r>
+            <a:endParaRPr lang="en-US" sz="8000" dirty="0"/>
+          </a:p>
+        </p:txBody>
+      </p:sp>
+      <p:pic>
+        <p:nvPicPr>
+          <p:cNvPr id="7" name="Image 1" descr="/Users/sov/bitcoincierge-pitch-deck 3/assets/processed/bitcoin_smiley.png">    </p:cNvPr>
+          <p:cNvPicPr>
+            <a:picLocks noChangeAspect="1"/>
+          </p:cNvPicPr>
+          <p:nvPr/>
+        </p:nvPicPr>
+        <p:blipFill>
+          <a:blip r:embed="rId2"/>
+          <a:stretch>
+            <a:fillRect/>
+          </a:stretch>
+        </p:blipFill>
+        <p:spPr>
+          <a:xfrm>
+            <a:off x="5486400" y="1371600"/>
+            <a:ext cx="2560320" cy="2560320"/>
+          </a:xfrm>
+          <a:prstGeom prst="rect">
+            <a:avLst/>
+          </a:prstGeom>
+        </p:spPr>
+      </p:pic>
     </p:spTree>
   </p:cSld>
   <p:clrMapOvr>
@@ -10855,7 +10392,7 @@
                 <a:ea typeface="Calibri" pitchFamily="34" charset="-122"/>
                 <a:cs typeface="Calibri" pitchFamily="34" charset="-120"/>
               </a:rPr>
-              <a:t>M A R K E T I N G   C H A N N E L   2   /   3</a:t>
+              <a:t>P A I D   M A R K E T I N G   P R O B L E M</a:t>
             </a:r>
             <a:endParaRPr lang="en-US" sz="850" dirty="0"/>
           </a:p>
@@ -10869,8 +10406,8 @@
         </p:nvSpPr>
         <p:spPr>
           <a:xfrm>
-            <a:off x="457200" y="475488"/>
-            <a:ext cx="8229600" cy="640080"/>
+            <a:off x="457200" y="411480"/>
+            <a:ext cx="8229600" cy="685800"/>
           </a:xfrm>
           <a:prstGeom prst="rect">
             <a:avLst/>
@@ -10886,7 +10423,7 @@
               <a:buNone/>
             </a:pPr>
             <a:r>
-              <a:rPr lang="en-US" sz="3600" i="1" dirty="0">
+              <a:rPr lang="en-US" sz="3200" i="1" dirty="0">
                 <a:solidFill>
                   <a:srgbClr val="1A1A1A"/>
                 </a:solidFill>
@@ -10894,67 +10431,46 @@
                 <a:ea typeface="Georgia" pitchFamily="34" charset="-122"/>
                 <a:cs typeface="Georgia" pitchFamily="34" charset="-120"/>
               </a:rPr>
-              <a:t>Go organic? 📱</a:t>
-            </a:r>
-            <a:endParaRPr lang="en-US" sz="3600" dirty="0"/>
-          </a:p>
-        </p:txBody>
-      </p:sp>
-      <p:sp>
-        <p:nvSpPr>
-          <p:cNvPr id="5" name="Shape 3"/>
-          <p:cNvSpPr/>
-          <p:nvPr/>
-        </p:nvSpPr>
-        <p:spPr>
-          <a:xfrm>
-            <a:off x="365760" y="1325880"/>
-            <a:ext cx="2697480" cy="3200400"/>
-          </a:xfrm>
-          <a:prstGeom prst="rect">
-            <a:avLst/>
-          </a:prstGeom>
-          <a:solidFill>
-            <a:srgbClr val="FCE8D5"/>
-          </a:solidFill>
-          <a:ln w="12700">
-            <a:solidFill>
-              <a:srgbClr val="F5C49A"/>
-            </a:solidFill>
-            <a:prstDash val="solid"/>
-          </a:ln>
-        </p:spPr>
-      </p:sp>
-      <p:sp>
-        <p:nvSpPr>
-          <p:cNvPr id="6" name="Shape 4"/>
-          <p:cNvSpPr/>
-          <p:nvPr/>
-        </p:nvSpPr>
-        <p:spPr>
-          <a:xfrm>
-            <a:off x="365760" y="1325880"/>
-            <a:ext cx="2697480" cy="50292"/>
-          </a:xfrm>
-          <a:prstGeom prst="rect">
-            <a:avLst/>
-          </a:prstGeom>
-          <a:solidFill>
-            <a:srgbClr val="DC2626"/>
-          </a:solidFill>
-          <a:ln/>
-        </p:spPr>
-      </p:sp>
-      <p:sp>
-        <p:nvSpPr>
-          <p:cNvPr id="7" name="Text 5"/>
-          <p:cNvSpPr/>
-          <p:nvPr/>
-        </p:nvSpPr>
-        <p:spPr>
-          <a:xfrm>
-            <a:off x="502920" y="1463040"/>
-            <a:ext cx="2423160" cy="1280160"/>
+              <a:t>Performance Media is pain</a:t>
+            </a:r>
+            <a:endParaRPr lang="en-US" sz="3200" dirty="0"/>
+          </a:p>
+        </p:txBody>
+      </p:sp>
+      <p:pic>
+        <p:nvPicPr>
+          <p:cNvPr id="5" name="Image 0" descr="/Users/sov/bitcoincierge-pitch-deck 3/assets/processed/google.png">    </p:cNvPr>
+          <p:cNvPicPr>
+            <a:picLocks noChangeAspect="1"/>
+          </p:cNvPicPr>
+          <p:nvPr/>
+        </p:nvPicPr>
+        <p:blipFill>
+          <a:blip r:embed="rId1"/>
+          <a:stretch>
+            <a:fillRect/>
+          </a:stretch>
+        </p:blipFill>
+        <p:spPr>
+          <a:xfrm>
+            <a:off x="1005840" y="1417320"/>
+            <a:ext cx="1463040" cy="1463040"/>
+          </a:xfrm>
+          <a:prstGeom prst="rect">
+            <a:avLst/>
+          </a:prstGeom>
+        </p:spPr>
+      </p:pic>
+      <p:sp>
+        <p:nvSpPr>
+          <p:cNvPr id="6" name="Text 3"/>
+          <p:cNvSpPr/>
+          <p:nvPr/>
+        </p:nvSpPr>
+        <p:spPr>
+          <a:xfrm>
+            <a:off x="502920" y="3017520"/>
+            <a:ext cx="2468880" cy="347472"/>
           </a:xfrm>
           <a:prstGeom prst="rect">
             <a:avLst/>
@@ -10970,30 +10486,30 @@
               <a:buNone/>
             </a:pPr>
             <a:r>
-              <a:rPr lang="en-US" sz="6000" dirty="0">
-                <a:solidFill>
-                  <a:srgbClr val="000000"/>
-                </a:solidFill>
-                <a:latin typeface="Calibri" pitchFamily="34" charset="0"/>
-                <a:ea typeface="Calibri" pitchFamily="34" charset="-122"/>
-                <a:cs typeface="Calibri" pitchFamily="34" charset="-120"/>
-              </a:rPr>
-              <a:t>🫥</a:t>
-            </a:r>
-            <a:endParaRPr lang="en-US" sz="6000" dirty="0"/>
-          </a:p>
-        </p:txBody>
-      </p:sp>
-      <p:sp>
-        <p:nvSpPr>
-          <p:cNvPr id="8" name="Text 6"/>
-          <p:cNvSpPr/>
-          <p:nvPr/>
-        </p:nvSpPr>
-        <p:spPr>
-          <a:xfrm>
-            <a:off x="457200" y="2880360"/>
-            <a:ext cx="2514600" cy="822960"/>
+              <a:rPr lang="en-US" sz="1300" b="1" dirty="0">
+                <a:solidFill>
+                  <a:srgbClr val="1A1A1A"/>
+                </a:solidFill>
+                <a:latin typeface="Calibri" pitchFamily="34" charset="0"/>
+                <a:ea typeface="Calibri" pitchFamily="34" charset="-122"/>
+                <a:cs typeface="Calibri" pitchFamily="34" charset="-120"/>
+              </a:rPr>
+              <a:t>Google</a:t>
+            </a:r>
+            <a:endParaRPr lang="en-US" sz="1300" dirty="0"/>
+          </a:p>
+        </p:txBody>
+      </p:sp>
+      <p:sp>
+        <p:nvSpPr>
+          <p:cNvPr id="7" name="Text 4"/>
+          <p:cNvSpPr/>
+          <p:nvPr/>
+        </p:nvSpPr>
+        <p:spPr>
+          <a:xfrm>
+            <a:off x="502920" y="3401568"/>
+            <a:ext cx="2468880" cy="594360"/>
           </a:xfrm>
           <a:prstGeom prst="rect">
             <a:avLst/>
@@ -11009,7 +10525,70 @@
               <a:buNone/>
             </a:pPr>
             <a:r>
-              <a:rPr lang="en-US" sz="2200" b="1" dirty="0">
+              <a:rPr lang="en-US" sz="1000" dirty="0">
+                <a:solidFill>
+                  <a:srgbClr val="8C5A3A"/>
+                </a:solidFill>
+                <a:latin typeface="Calibri" pitchFamily="34" charset="0"/>
+                <a:ea typeface="Calibri" pitchFamily="34" charset="-122"/>
+                <a:cs typeface="Calibri" pitchFamily="34" charset="-120"/>
+              </a:rPr>
+              <a:t>Requires certification and compliance</a:t>
+            </a:r>
+            <a:endParaRPr lang="en-US" sz="1000" dirty="0"/>
+          </a:p>
+        </p:txBody>
+      </p:sp>
+      <p:pic>
+        <p:nvPicPr>
+          <p:cNvPr id="8" name="Image 1" descr="/Users/sov/bitcoincierge-pitch-deck 3/assets/processed/meta.png">    </p:cNvPr>
+          <p:cNvPicPr>
+            <a:picLocks noChangeAspect="1"/>
+          </p:cNvPicPr>
+          <p:nvPr/>
+        </p:nvPicPr>
+        <p:blipFill>
+          <a:blip r:embed="rId2"/>
+          <a:stretch>
+            <a:fillRect/>
+          </a:stretch>
+        </p:blipFill>
+        <p:spPr>
+          <a:xfrm>
+            <a:off x="3840480" y="1417320"/>
+            <a:ext cx="1463040" cy="1463040"/>
+          </a:xfrm>
+          <a:prstGeom prst="rect">
+            <a:avLst/>
+          </a:prstGeom>
+        </p:spPr>
+      </p:pic>
+      <p:sp>
+        <p:nvSpPr>
+          <p:cNvPr id="9" name="Text 5"/>
+          <p:cNvSpPr/>
+          <p:nvPr/>
+        </p:nvSpPr>
+        <p:spPr>
+          <a:xfrm>
+            <a:off x="3337560" y="3017520"/>
+            <a:ext cx="2468880" cy="347472"/>
+          </a:xfrm>
+          <a:prstGeom prst="rect">
+            <a:avLst/>
+          </a:prstGeom>
+          <a:noFill/>
+          <a:ln/>
+        </p:spPr>
+        <p:txBody>
+          <a:bodyPr wrap="square" lIns="0" tIns="0" rIns="0" bIns="0" rtlCol="0" anchor="ctr"/>
+          <a:lstStyle/>
+          <a:p>
+            <a:pPr algn="ctr" indent="0" marL="0">
+              <a:buNone/>
+            </a:pPr>
+            <a:r>
+              <a:rPr lang="en-US" sz="1300" b="1" dirty="0">
                 <a:solidFill>
                   <a:srgbClr val="1A1A1A"/>
                 </a:solidFill>
@@ -11017,67 +10596,22 @@
                 <a:ea typeface="Calibri" pitchFamily="34" charset="-122"/>
                 <a:cs typeface="Calibri" pitchFamily="34" charset="-120"/>
               </a:rPr>
-              <a:t>Shadow Banning</a:t>
-            </a:r>
-            <a:endParaRPr lang="en-US" sz="2200" dirty="0"/>
-          </a:p>
-        </p:txBody>
-      </p:sp>
-      <p:sp>
-        <p:nvSpPr>
-          <p:cNvPr id="9" name="Shape 7"/>
-          <p:cNvSpPr/>
-          <p:nvPr/>
-        </p:nvSpPr>
-        <p:spPr>
-          <a:xfrm>
-            <a:off x="3200400" y="1325880"/>
-            <a:ext cx="2697480" cy="3200400"/>
-          </a:xfrm>
-          <a:prstGeom prst="rect">
-            <a:avLst/>
-          </a:prstGeom>
-          <a:solidFill>
-            <a:srgbClr val="FCE8D5"/>
-          </a:solidFill>
-          <a:ln w="12700">
-            <a:solidFill>
-              <a:srgbClr val="F5C49A"/>
-            </a:solidFill>
-            <a:prstDash val="solid"/>
-          </a:ln>
-        </p:spPr>
-      </p:sp>
-      <p:sp>
-        <p:nvSpPr>
-          <p:cNvPr id="10" name="Shape 8"/>
-          <p:cNvSpPr/>
-          <p:nvPr/>
-        </p:nvSpPr>
-        <p:spPr>
-          <a:xfrm>
-            <a:off x="3200400" y="1325880"/>
-            <a:ext cx="2697480" cy="50292"/>
-          </a:xfrm>
-          <a:prstGeom prst="rect">
-            <a:avLst/>
-          </a:prstGeom>
-          <a:solidFill>
-            <a:srgbClr val="DC2626"/>
-          </a:solidFill>
-          <a:ln/>
-        </p:spPr>
-      </p:sp>
-      <p:sp>
-        <p:nvSpPr>
-          <p:cNvPr id="11" name="Text 9"/>
-          <p:cNvSpPr/>
-          <p:nvPr/>
-        </p:nvSpPr>
-        <p:spPr>
-          <a:xfrm>
-            <a:off x="3337560" y="1463040"/>
-            <a:ext cx="2423160" cy="1280160"/>
+              <a:t>Meta / Facebook</a:t>
+            </a:r>
+            <a:endParaRPr lang="en-US" sz="1300" dirty="0"/>
+          </a:p>
+        </p:txBody>
+      </p:sp>
+      <p:sp>
+        <p:nvSpPr>
+          <p:cNvPr id="10" name="Text 6"/>
+          <p:cNvSpPr/>
+          <p:nvPr/>
+        </p:nvSpPr>
+        <p:spPr>
+          <a:xfrm>
+            <a:off x="3337560" y="3401568"/>
+            <a:ext cx="2468880" cy="594360"/>
           </a:xfrm>
           <a:prstGeom prst="rect">
             <a:avLst/>
@@ -11093,30 +10627,54 @@
               <a:buNone/>
             </a:pPr>
             <a:r>
-              <a:rPr lang="en-US" sz="6000" dirty="0">
-                <a:solidFill>
-                  <a:srgbClr val="000000"/>
-                </a:solidFill>
-                <a:latin typeface="Calibri" pitchFamily="34" charset="0"/>
-                <a:ea typeface="Calibri" pitchFamily="34" charset="-122"/>
-                <a:cs typeface="Calibri" pitchFamily="34" charset="-120"/>
-              </a:rPr>
-              <a:t>🤖</a:t>
-            </a:r>
-            <a:endParaRPr lang="en-US" sz="6000" dirty="0"/>
-          </a:p>
-        </p:txBody>
-      </p:sp>
-      <p:sp>
-        <p:nvSpPr>
-          <p:cNvPr id="12" name="Text 10"/>
-          <p:cNvSpPr/>
-          <p:nvPr/>
-        </p:nvSpPr>
-        <p:spPr>
-          <a:xfrm>
-            <a:off x="3291840" y="2880360"/>
-            <a:ext cx="2514600" cy="822960"/>
+              <a:rPr lang="en-US" sz="1000" dirty="0">
+                <a:solidFill>
+                  <a:srgbClr val="8C5A3A"/>
+                </a:solidFill>
+                <a:latin typeface="Calibri" pitchFamily="34" charset="0"/>
+                <a:ea typeface="Calibri" pitchFamily="34" charset="-122"/>
+                <a:cs typeface="Calibri" pitchFamily="34" charset="-120"/>
+              </a:rPr>
+              <a:t>Requires prior permission. Often denied.</a:t>
+            </a:r>
+            <a:endParaRPr lang="en-US" sz="1000" dirty="0"/>
+          </a:p>
+        </p:txBody>
+      </p:sp>
+      <p:pic>
+        <p:nvPicPr>
+          <p:cNvPr id="11" name="Image 2" descr="/Users/sov/bitcoincierge-pitch-deck 3/assets/processed/x_logo.png">    </p:cNvPr>
+          <p:cNvPicPr>
+            <a:picLocks noChangeAspect="1"/>
+          </p:cNvPicPr>
+          <p:nvPr/>
+        </p:nvPicPr>
+        <p:blipFill>
+          <a:blip r:embed="rId3"/>
+          <a:stretch>
+            <a:fillRect/>
+          </a:stretch>
+        </p:blipFill>
+        <p:spPr>
+          <a:xfrm>
+            <a:off x="6675120" y="1417320"/>
+            <a:ext cx="1463040" cy="1463040"/>
+          </a:xfrm>
+          <a:prstGeom prst="rect">
+            <a:avLst/>
+          </a:prstGeom>
+        </p:spPr>
+      </p:pic>
+      <p:sp>
+        <p:nvSpPr>
+          <p:cNvPr id="12" name="Text 7"/>
+          <p:cNvSpPr/>
+          <p:nvPr/>
+        </p:nvSpPr>
+        <p:spPr>
+          <a:xfrm>
+            <a:off x="6172200" y="3017520"/>
+            <a:ext cx="2468880" cy="347472"/>
           </a:xfrm>
           <a:prstGeom prst="rect">
             <a:avLst/>
@@ -11132,7 +10690,7 @@
               <a:buNone/>
             </a:pPr>
             <a:r>
-              <a:rPr lang="en-US" sz="2200" b="1" dirty="0">
+              <a:rPr lang="en-US" sz="1300" b="1" dirty="0">
                 <a:solidFill>
                   <a:srgbClr val="1A1A1A"/>
                 </a:solidFill>
@@ -11140,67 +10698,22 @@
                 <a:ea typeface="Calibri" pitchFamily="34" charset="-122"/>
                 <a:cs typeface="Calibri" pitchFamily="34" charset="-120"/>
               </a:rPr>
-              <a:t>AI Slop</a:t>
-            </a:r>
-            <a:endParaRPr lang="en-US" sz="2200" dirty="0"/>
-          </a:p>
-        </p:txBody>
-      </p:sp>
-      <p:sp>
-        <p:nvSpPr>
-          <p:cNvPr id="13" name="Shape 11"/>
-          <p:cNvSpPr/>
-          <p:nvPr/>
-        </p:nvSpPr>
-        <p:spPr>
-          <a:xfrm>
-            <a:off x="6035040" y="1325880"/>
-            <a:ext cx="2697480" cy="3200400"/>
-          </a:xfrm>
-          <a:prstGeom prst="rect">
-            <a:avLst/>
-          </a:prstGeom>
-          <a:solidFill>
-            <a:srgbClr val="FCE8D5"/>
-          </a:solidFill>
-          <a:ln w="12700">
-            <a:solidFill>
-              <a:srgbClr val="F5C49A"/>
-            </a:solidFill>
-            <a:prstDash val="solid"/>
-          </a:ln>
-        </p:spPr>
-      </p:sp>
-      <p:sp>
-        <p:nvSpPr>
-          <p:cNvPr id="14" name="Shape 12"/>
-          <p:cNvSpPr/>
-          <p:nvPr/>
-        </p:nvSpPr>
-        <p:spPr>
-          <a:xfrm>
-            <a:off x="6035040" y="1325880"/>
-            <a:ext cx="2697480" cy="50292"/>
-          </a:xfrm>
-          <a:prstGeom prst="rect">
-            <a:avLst/>
-          </a:prstGeom>
-          <a:solidFill>
-            <a:srgbClr val="DC2626"/>
-          </a:solidFill>
-          <a:ln/>
-        </p:spPr>
-      </p:sp>
-      <p:sp>
-        <p:nvSpPr>
-          <p:cNvPr id="15" name="Text 13"/>
-          <p:cNvSpPr/>
-          <p:nvPr/>
-        </p:nvSpPr>
-        <p:spPr>
-          <a:xfrm>
-            <a:off x="6172200" y="1463040"/>
-            <a:ext cx="2423160" cy="1280160"/>
+              <a:t>Twitter / X</a:t>
+            </a:r>
+            <a:endParaRPr lang="en-US" sz="1300" dirty="0"/>
+          </a:p>
+        </p:txBody>
+      </p:sp>
+      <p:sp>
+        <p:nvSpPr>
+          <p:cNvPr id="13" name="Text 8"/>
+          <p:cNvSpPr/>
+          <p:nvPr/>
+        </p:nvSpPr>
+        <p:spPr>
+          <a:xfrm>
+            <a:off x="6172200" y="3401568"/>
+            <a:ext cx="2468880" cy="594360"/>
           </a:xfrm>
           <a:prstGeom prst="rect">
             <a:avLst/>
@@ -11216,56 +10729,17 @@
               <a:buNone/>
             </a:pPr>
             <a:r>
-              <a:rPr lang="en-US" sz="6000" dirty="0">
-                <a:solidFill>
-                  <a:srgbClr val="000000"/>
-                </a:solidFill>
-                <a:latin typeface="Calibri" pitchFamily="34" charset="0"/>
-                <a:ea typeface="Calibri" pitchFamily="34" charset="-122"/>
-                <a:cs typeface="Calibri" pitchFamily="34" charset="-120"/>
-              </a:rPr>
-              <a:t>😮‍💨</a:t>
-            </a:r>
-            <a:endParaRPr lang="en-US" sz="6000" dirty="0"/>
-          </a:p>
-        </p:txBody>
-      </p:sp>
-      <p:sp>
-        <p:nvSpPr>
-          <p:cNvPr id="16" name="Text 14"/>
-          <p:cNvSpPr/>
-          <p:nvPr/>
-        </p:nvSpPr>
-        <p:spPr>
-          <a:xfrm>
-            <a:off x="6126480" y="2880360"/>
-            <a:ext cx="2514600" cy="822960"/>
-          </a:xfrm>
-          <a:prstGeom prst="rect">
-            <a:avLst/>
-          </a:prstGeom>
-          <a:noFill/>
-          <a:ln/>
-        </p:spPr>
-        <p:txBody>
-          <a:bodyPr wrap="square" lIns="0" tIns="0" rIns="0" bIns="0" rtlCol="0" anchor="ctr"/>
-          <a:lstStyle/>
-          <a:p>
-            <a:pPr algn="ctr" indent="0" marL="0">
-              <a:buNone/>
-            </a:pPr>
-            <a:r>
-              <a:rPr lang="en-US" sz="2200" b="1" dirty="0">
-                <a:solidFill>
-                  <a:srgbClr val="1A1A1A"/>
-                </a:solidFill>
-                <a:latin typeface="Calibri" pitchFamily="34" charset="0"/>
-                <a:ea typeface="Calibri" pitchFamily="34" charset="-122"/>
-                <a:cs typeface="Calibri" pitchFamily="34" charset="-120"/>
-              </a:rPr>
-              <a:t>Social Media Fatigue</a:t>
-            </a:r>
-            <a:endParaRPr lang="en-US" sz="2200" dirty="0"/>
+              <a:rPr lang="en-US" sz="1000" dirty="0">
+                <a:solidFill>
+                  <a:srgbClr val="8C5A3A"/>
+                </a:solidFill>
+                <a:latin typeface="Calibri" pitchFamily="34" charset="0"/>
+                <a:ea typeface="Calibri" pitchFamily="34" charset="-122"/>
+                <a:cs typeface="Calibri" pitchFamily="34" charset="-120"/>
+              </a:rPr>
+              <a:t>Requires certification.</a:t>
+            </a:r>
+            <a:endParaRPr lang="en-US" sz="1000" dirty="0"/>
           </a:p>
         </p:txBody>
       </p:sp>
@@ -11354,7 +10828,7 @@
                 <a:ea typeface="Calibri" pitchFamily="34" charset="-122"/>
                 <a:cs typeface="Calibri" pitchFamily="34" charset="-120"/>
               </a:rPr>
-              <a:t>M A R K E T I N G   C H A N N E L   3   /   3</a:t>
+              <a:t>C U R R E N T   W O R K A R O U N D S</a:t>
             </a:r>
             <a:endParaRPr lang="en-US" sz="850" dirty="0"/>
           </a:p>
@@ -11393,7 +10867,7 @@
                 <a:ea typeface="Georgia" pitchFamily="34" charset="-122"/>
                 <a:cs typeface="Georgia" pitchFamily="34" charset="-120"/>
               </a:rPr>
-              <a:t>Pay to play? 💸</a:t>
+              <a:t>Big brands have figured 💸</a:t>
             </a:r>
             <a:endParaRPr lang="en-US" sz="3600" dirty="0"/>
           </a:p>
@@ -11692,7 +11166,7 @@
                 <a:ea typeface="Calibri" pitchFamily="34" charset="-122"/>
                 <a:cs typeface="Calibri" pitchFamily="34" charset="-120"/>
               </a:rPr>
-              <a:t>For Coinbase. Not for your seed-stage startup.</a:t>
+              <a:t>May not be for many of us!</a:t>
             </a:r>
             <a:endParaRPr lang="en-US" sz="900" dirty="0"/>
           </a:p>
@@ -11932,7 +11406,7 @@
                 <a:ea typeface="Calibri" pitchFamily="34" charset="-122"/>
                 <a:cs typeface="Calibri" pitchFamily="34" charset="-120"/>
               </a:rPr>
-              <a:t>Top 10 Indian Bitcoin creators</a:t>
+              <a:t>Top 10 Indian creators</a:t>
             </a:r>
             <a:endParaRPr lang="en-US" sz="900" dirty="0"/>
           </a:p>
@@ -11991,7 +11465,7 @@
                 <a:ea typeface="Calibri" pitchFamily="34" charset="-122"/>
                 <a:cs typeface="Calibri" pitchFamily="34" charset="-120"/>
               </a:rPr>
-              <a:t>No guaranteed conversion. No attribution. No retargeting.</a:t>
+              <a:t>No assured conversion, or attribution.</a:t>
             </a:r>
             <a:endParaRPr lang="en-US" sz="900" dirty="0"/>
           </a:p>
@@ -12121,24 +11595,7 @@
                 <a:ea typeface="Georgia" pitchFamily="34" charset="-122"/>
                 <a:cs typeface="Georgia" pitchFamily="34" charset="-120"/>
               </a:rPr>
-              <a:t>Smart founders already</a:t>
-            </a:r>
-            <a:endParaRPr lang="en-US" sz="3000" dirty="0"/>
-          </a:p>
-          <a:p>
-            <a:pPr algn="l" indent="0" marL="0">
-              <a:buNone/>
-            </a:pPr>
-            <a:r>
-              <a:rPr lang="en-US" sz="3000" i="1" dirty="0">
-                <a:solidFill>
-                  <a:srgbClr val="1A1A1A"/>
-                </a:solidFill>
-                <a:latin typeface="Georgia" pitchFamily="34" charset="0"/>
-                <a:ea typeface="Georgia" pitchFamily="34" charset="-122"/>
-                <a:cs typeface="Georgia" pitchFamily="34" charset="-120"/>
-              </a:rPr>
-              <a:t>figured it out.</a:t>
+              <a:t>Smart founders are figuring</a:t>
             </a:r>
             <a:endParaRPr lang="en-US" sz="3000" dirty="0"/>
           </a:p>
@@ -12844,7 +12301,7 @@
                 <a:ea typeface="Calibri" pitchFamily="34" charset="-122"/>
                 <a:cs typeface="Calibri" pitchFamily="34" charset="-120"/>
               </a:rPr>
-              <a:t>B U T   T H I S   M O D E L   H A S   P R O B L E M S</a:t>
+              <a:t>T H E   B I G   P R O B L E M</a:t>
             </a:r>
             <a:endParaRPr lang="en-US" sz="850" dirty="0"/>
           </a:p>
@@ -12903,24 +12360,7 @@
                 <a:ea typeface="Georgia" pitchFamily="34" charset="-122"/>
                 <a:cs typeface="Georgia" pitchFamily="34" charset="-120"/>
               </a:rPr>
-              <a:t>Building your own community</a:t>
-            </a:r>
-            <a:endParaRPr lang="en-US" sz="3000" dirty="0"/>
-          </a:p>
-          <a:p>
-            <a:pPr algn="l" indent="0" marL="0">
-              <a:buNone/>
-            </a:pPr>
-            <a:r>
-              <a:rPr lang="en-US" sz="3000" i="1" dirty="0">
-                <a:solidFill>
-                  <a:srgbClr val="1A1A1A"/>
-                </a:solidFill>
-                <a:latin typeface="Georgia" pitchFamily="34" charset="0"/>
-                <a:ea typeface="Georgia" pitchFamily="34" charset="-122"/>
-                <a:cs typeface="Georgia" pitchFamily="34" charset="-120"/>
-              </a:rPr>
-              <a:t>breaks at scale.</a:t>
+              <a:t>Before you jump this route!</a:t>
             </a:r>
             <a:endParaRPr lang="en-US" sz="3000" dirty="0"/>
           </a:p>

</xml_diff>